<commit_message>
feat: implementacion de comparativa de tokenizadores, generador de ponencias premium y explicacion interactiva del modelo
</commit_message>
<xml_diff>
--- a/tesis_defensa_nmt_aimara_v2.pptx
+++ b/tesis_defensa_nmt_aimara_v2.pptx
@@ -5,20 +5,20 @@
     <p:sldMasterId id="2147483648" r:id="rId1"/>
   </p:sldMasterIdLst>
   <p:sldIdLst>
-    <p:sldId id="256" r:id="rId7"/>
-    <p:sldId id="257" r:id="rId8"/>
-    <p:sldId id="258" r:id="rId9"/>
-    <p:sldId id="259" r:id="rId10"/>
-    <p:sldId id="260" r:id="rId11"/>
-    <p:sldId id="261" r:id="rId12"/>
-    <p:sldId id="262" r:id="rId13"/>
-    <p:sldId id="263" r:id="rId14"/>
-    <p:sldId id="264" r:id="rId15"/>
-    <p:sldId id="265" r:id="rId16"/>
-    <p:sldId id="266" r:id="rId17"/>
-    <p:sldId id="267" r:id="rId18"/>
+    <p:sldId id="256" r:id="rId2"/>
+    <p:sldId id="257" r:id="rId3"/>
+    <p:sldId id="258" r:id="rId4"/>
+    <p:sldId id="259" r:id="rId5"/>
+    <p:sldId id="260" r:id="rId6"/>
+    <p:sldId id="261" r:id="rId7"/>
+    <p:sldId id="262" r:id="rId8"/>
+    <p:sldId id="263" r:id="rId9"/>
+    <p:sldId id="264" r:id="rId10"/>
+    <p:sldId id="265" r:id="rId11"/>
+    <p:sldId id="266" r:id="rId12"/>
+    <p:sldId id="267" r:id="rId13"/>
   </p:sldIdLst>
-  <p:sldSz cx="12188952" cy="6858000" type="screen4x3"/>
+  <p:sldSz cx="12188825" cy="6858000"/>
   <p:notesSz cx="6858000" cy="9144000"/>
   <p:defaultTextStyle>
     <a:defPPr>
@@ -115,6 +115,22 @@
       </a:defRPr>
     </a:lvl9pPr>
   </p:defaultTextStyle>
+  <p:extLst>
+    <p:ext uri="{EFAFB233-063F-42B5-8137-9DF3F51BA10A}">
+      <p15:sldGuideLst xmlns:p15="http://schemas.microsoft.com/office/powerpoint/2012/main">
+        <p15:guide id="1" orient="horz" pos="2160">
+          <p15:clr>
+            <a:srgbClr val="A4A3A4"/>
+          </p15:clr>
+        </p15:guide>
+        <p15:guide id="2" pos="2880">
+          <p15:clr>
+            <a:srgbClr val="A4A3A4"/>
+          </p15:clr>
+        </p15:guide>
+      </p15:sldGuideLst>
+    </p:ext>
+  </p:extLst>
 </p:presentation>
 </file>
 
@@ -156,10 +172,9 @@
           <a:lstStyle/>
           <a:p>
             <a:r>
-              <a:rPr lang="en-US" smtClean="0"/>
+              <a:rPr lang="en-US"/>
               <a:t>Click to edit Master title style</a:t>
             </a:r>
-            <a:endParaRPr lang="en-US"/>
           </a:p>
         </p:txBody>
       </p:sp>
@@ -275,10 +290,9 @@
           </a:lstStyle>
           <a:p>
             <a:r>
-              <a:rPr lang="en-US" smtClean="0"/>
+              <a:rPr lang="en-US"/>
               <a:t>Click to edit Master subtitle style</a:t>
             </a:r>
-            <a:endParaRPr lang="en-US"/>
           </a:p>
         </p:txBody>
       </p:sp>
@@ -299,7 +313,7 @@
           <a:p>
             <a:fld id="{5BCAD085-E8A6-8845-BD4E-CB4CCA059FC4}" type="datetimeFigureOut">
               <a:rPr lang="en-US" smtClean="0"/>
-              <a:t>1/27/13</a:t>
+              <a:t>5/25/2026</a:t>
             </a:fld>
             <a:endParaRPr lang="en-US"/>
           </a:p>
@@ -341,7 +355,7 @@
           <a:p>
             <a:fld id="{C1FF6DA9-008F-8B48-92A6-B652298478BF}" type="slidenum">
               <a:rPr lang="en-US" smtClean="0"/>
-              <a:t>‹#›</a:t>
+              <a:t>‹Nº›</a:t>
             </a:fld>
             <a:endParaRPr lang="en-US"/>
           </a:p>
@@ -393,10 +407,9 @@
           <a:lstStyle/>
           <a:p>
             <a:r>
-              <a:rPr lang="en-US" smtClean="0"/>
+              <a:rPr lang="en-US"/>
               <a:t>Click to edit Master title style</a:t>
             </a:r>
-            <a:endParaRPr lang="en-US"/>
           </a:p>
         </p:txBody>
       </p:sp>
@@ -417,38 +430,37 @@
           <a:p>
             <a:pPr lvl="0"/>
             <a:r>
-              <a:rPr lang="en-US" smtClean="0"/>
+              <a:rPr lang="en-US"/>
               <a:t>Click to edit Master text styles</a:t>
             </a:r>
           </a:p>
           <a:p>
             <a:pPr lvl="1"/>
             <a:r>
-              <a:rPr lang="en-US" smtClean="0"/>
+              <a:rPr lang="en-US"/>
               <a:t>Second level</a:t>
             </a:r>
           </a:p>
           <a:p>
             <a:pPr lvl="2"/>
             <a:r>
-              <a:rPr lang="en-US" smtClean="0"/>
+              <a:rPr lang="en-US"/>
               <a:t>Third level</a:t>
             </a:r>
           </a:p>
           <a:p>
             <a:pPr lvl="3"/>
             <a:r>
-              <a:rPr lang="en-US" smtClean="0"/>
+              <a:rPr lang="en-US"/>
               <a:t>Fourth level</a:t>
             </a:r>
           </a:p>
           <a:p>
             <a:pPr lvl="4"/>
             <a:r>
-              <a:rPr lang="en-US" smtClean="0"/>
+              <a:rPr lang="en-US"/>
               <a:t>Fifth level</a:t>
             </a:r>
-            <a:endParaRPr lang="en-US"/>
           </a:p>
         </p:txBody>
       </p:sp>
@@ -469,7 +481,7 @@
           <a:p>
             <a:fld id="{5BCAD085-E8A6-8845-BD4E-CB4CCA059FC4}" type="datetimeFigureOut">
               <a:rPr lang="en-US" smtClean="0"/>
-              <a:t>1/27/13</a:t>
+              <a:t>5/25/2026</a:t>
             </a:fld>
             <a:endParaRPr lang="en-US"/>
           </a:p>
@@ -511,7 +523,7 @@
           <a:p>
             <a:fld id="{C1FF6DA9-008F-8B48-92A6-B652298478BF}" type="slidenum">
               <a:rPr lang="en-US" smtClean="0"/>
-              <a:t>‹#›</a:t>
+              <a:t>‹Nº›</a:t>
             </a:fld>
             <a:endParaRPr lang="en-US"/>
           </a:p>
@@ -568,10 +580,9 @@
           <a:lstStyle/>
           <a:p>
             <a:r>
-              <a:rPr lang="en-US" smtClean="0"/>
+              <a:rPr lang="en-US"/>
               <a:t>Click to edit Master title style</a:t>
             </a:r>
-            <a:endParaRPr lang="en-US"/>
           </a:p>
         </p:txBody>
       </p:sp>
@@ -597,38 +608,37 @@
           <a:p>
             <a:pPr lvl="0"/>
             <a:r>
-              <a:rPr lang="en-US" smtClean="0"/>
+              <a:rPr lang="en-US"/>
               <a:t>Click to edit Master text styles</a:t>
             </a:r>
           </a:p>
           <a:p>
             <a:pPr lvl="1"/>
             <a:r>
-              <a:rPr lang="en-US" smtClean="0"/>
+              <a:rPr lang="en-US"/>
               <a:t>Second level</a:t>
             </a:r>
           </a:p>
           <a:p>
             <a:pPr lvl="2"/>
             <a:r>
-              <a:rPr lang="en-US" smtClean="0"/>
+              <a:rPr lang="en-US"/>
               <a:t>Third level</a:t>
             </a:r>
           </a:p>
           <a:p>
             <a:pPr lvl="3"/>
             <a:r>
-              <a:rPr lang="en-US" smtClean="0"/>
+              <a:rPr lang="en-US"/>
               <a:t>Fourth level</a:t>
             </a:r>
           </a:p>
           <a:p>
             <a:pPr lvl="4"/>
             <a:r>
-              <a:rPr lang="en-US" smtClean="0"/>
+              <a:rPr lang="en-US"/>
               <a:t>Fifth level</a:t>
             </a:r>
-            <a:endParaRPr lang="en-US"/>
           </a:p>
         </p:txBody>
       </p:sp>
@@ -649,7 +659,7 @@
           <a:p>
             <a:fld id="{5BCAD085-E8A6-8845-BD4E-CB4CCA059FC4}" type="datetimeFigureOut">
               <a:rPr lang="en-US" smtClean="0"/>
-              <a:t>1/27/13</a:t>
+              <a:t>5/25/2026</a:t>
             </a:fld>
             <a:endParaRPr lang="en-US"/>
           </a:p>
@@ -691,7 +701,7 @@
           <a:p>
             <a:fld id="{C1FF6DA9-008F-8B48-92A6-B652298478BF}" type="slidenum">
               <a:rPr lang="en-US" smtClean="0"/>
-              <a:t>‹#›</a:t>
+              <a:t>‹Nº›</a:t>
             </a:fld>
             <a:endParaRPr lang="en-US"/>
           </a:p>
@@ -743,10 +753,9 @@
           <a:lstStyle/>
           <a:p>
             <a:r>
-              <a:rPr lang="en-US" smtClean="0"/>
+              <a:rPr lang="en-US"/>
               <a:t>Click to edit Master title style</a:t>
             </a:r>
-            <a:endParaRPr lang="en-US"/>
           </a:p>
         </p:txBody>
       </p:sp>
@@ -767,38 +776,37 @@
           <a:p>
             <a:pPr lvl="0"/>
             <a:r>
-              <a:rPr lang="en-US" smtClean="0"/>
+              <a:rPr lang="en-US"/>
               <a:t>Click to edit Master text styles</a:t>
             </a:r>
           </a:p>
           <a:p>
             <a:pPr lvl="1"/>
             <a:r>
-              <a:rPr lang="en-US" smtClean="0"/>
+              <a:rPr lang="en-US"/>
               <a:t>Second level</a:t>
             </a:r>
           </a:p>
           <a:p>
             <a:pPr lvl="2"/>
             <a:r>
-              <a:rPr lang="en-US" smtClean="0"/>
+              <a:rPr lang="en-US"/>
               <a:t>Third level</a:t>
             </a:r>
           </a:p>
           <a:p>
             <a:pPr lvl="3"/>
             <a:r>
-              <a:rPr lang="en-US" smtClean="0"/>
+              <a:rPr lang="en-US"/>
               <a:t>Fourth level</a:t>
             </a:r>
           </a:p>
           <a:p>
             <a:pPr lvl="4"/>
             <a:r>
-              <a:rPr lang="en-US" smtClean="0"/>
+              <a:rPr lang="en-US"/>
               <a:t>Fifth level</a:t>
             </a:r>
-            <a:endParaRPr lang="en-US"/>
           </a:p>
         </p:txBody>
       </p:sp>
@@ -819,7 +827,7 @@
           <a:p>
             <a:fld id="{5BCAD085-E8A6-8845-BD4E-CB4CCA059FC4}" type="datetimeFigureOut">
               <a:rPr lang="en-US" smtClean="0"/>
-              <a:t>1/27/13</a:t>
+              <a:t>5/25/2026</a:t>
             </a:fld>
             <a:endParaRPr lang="en-US"/>
           </a:p>
@@ -861,7 +869,7 @@
           <a:p>
             <a:fld id="{C1FF6DA9-008F-8B48-92A6-B652298478BF}" type="slidenum">
               <a:rPr lang="en-US" smtClean="0"/>
-              <a:t>‹#›</a:t>
+              <a:t>‹Nº›</a:t>
             </a:fld>
             <a:endParaRPr lang="en-US"/>
           </a:p>
@@ -922,10 +930,9 @@
           </a:lstStyle>
           <a:p>
             <a:r>
-              <a:rPr lang="en-US" smtClean="0"/>
+              <a:rPr lang="en-US"/>
               <a:t>Click to edit Master title style</a:t>
             </a:r>
-            <a:endParaRPr lang="en-US"/>
           </a:p>
         </p:txBody>
       </p:sp>
@@ -1042,7 +1049,7 @@
           <a:p>
             <a:pPr lvl="0"/>
             <a:r>
-              <a:rPr lang="en-US" smtClean="0"/>
+              <a:rPr lang="en-US"/>
               <a:t>Click to edit Master text styles</a:t>
             </a:r>
           </a:p>
@@ -1065,7 +1072,7 @@
           <a:p>
             <a:fld id="{5BCAD085-E8A6-8845-BD4E-CB4CCA059FC4}" type="datetimeFigureOut">
               <a:rPr lang="en-US" smtClean="0"/>
-              <a:t>1/27/13</a:t>
+              <a:t>5/25/2026</a:t>
             </a:fld>
             <a:endParaRPr lang="en-US"/>
           </a:p>
@@ -1107,7 +1114,7 @@
           <a:p>
             <a:fld id="{C1FF6DA9-008F-8B48-92A6-B652298478BF}" type="slidenum">
               <a:rPr lang="en-US" smtClean="0"/>
-              <a:t>‹#›</a:t>
+              <a:t>‹Nº›</a:t>
             </a:fld>
             <a:endParaRPr lang="en-US"/>
           </a:p>
@@ -1159,10 +1166,9 @@
           <a:lstStyle/>
           <a:p>
             <a:r>
-              <a:rPr lang="en-US" smtClean="0"/>
+              <a:rPr lang="en-US"/>
               <a:t>Click to edit Master title style</a:t>
             </a:r>
-            <a:endParaRPr lang="en-US"/>
           </a:p>
         </p:txBody>
       </p:sp>
@@ -1216,38 +1222,37 @@
           <a:p>
             <a:pPr lvl="0"/>
             <a:r>
-              <a:rPr lang="en-US" smtClean="0"/>
+              <a:rPr lang="en-US"/>
               <a:t>Click to edit Master text styles</a:t>
             </a:r>
           </a:p>
           <a:p>
             <a:pPr lvl="1"/>
             <a:r>
-              <a:rPr lang="en-US" smtClean="0"/>
+              <a:rPr lang="en-US"/>
               <a:t>Second level</a:t>
             </a:r>
           </a:p>
           <a:p>
             <a:pPr lvl="2"/>
             <a:r>
-              <a:rPr lang="en-US" smtClean="0"/>
+              <a:rPr lang="en-US"/>
               <a:t>Third level</a:t>
             </a:r>
           </a:p>
           <a:p>
             <a:pPr lvl="3"/>
             <a:r>
-              <a:rPr lang="en-US" smtClean="0"/>
+              <a:rPr lang="en-US"/>
               <a:t>Fourth level</a:t>
             </a:r>
           </a:p>
           <a:p>
             <a:pPr lvl="4"/>
             <a:r>
-              <a:rPr lang="en-US" smtClean="0"/>
+              <a:rPr lang="en-US"/>
               <a:t>Fifth level</a:t>
             </a:r>
-            <a:endParaRPr lang="en-US"/>
           </a:p>
         </p:txBody>
       </p:sp>
@@ -1301,38 +1306,37 @@
           <a:p>
             <a:pPr lvl="0"/>
             <a:r>
-              <a:rPr lang="en-US" smtClean="0"/>
+              <a:rPr lang="en-US"/>
               <a:t>Click to edit Master text styles</a:t>
             </a:r>
           </a:p>
           <a:p>
             <a:pPr lvl="1"/>
             <a:r>
-              <a:rPr lang="en-US" smtClean="0"/>
+              <a:rPr lang="en-US"/>
               <a:t>Second level</a:t>
             </a:r>
           </a:p>
           <a:p>
             <a:pPr lvl="2"/>
             <a:r>
-              <a:rPr lang="en-US" smtClean="0"/>
+              <a:rPr lang="en-US"/>
               <a:t>Third level</a:t>
             </a:r>
           </a:p>
           <a:p>
             <a:pPr lvl="3"/>
             <a:r>
-              <a:rPr lang="en-US" smtClean="0"/>
+              <a:rPr lang="en-US"/>
               <a:t>Fourth level</a:t>
             </a:r>
           </a:p>
           <a:p>
             <a:pPr lvl="4"/>
             <a:r>
-              <a:rPr lang="en-US" smtClean="0"/>
+              <a:rPr lang="en-US"/>
               <a:t>Fifth level</a:t>
             </a:r>
-            <a:endParaRPr lang="en-US"/>
           </a:p>
         </p:txBody>
       </p:sp>
@@ -1353,7 +1357,7 @@
           <a:p>
             <a:fld id="{5BCAD085-E8A6-8845-BD4E-CB4CCA059FC4}" type="datetimeFigureOut">
               <a:rPr lang="en-US" smtClean="0"/>
-              <a:t>1/27/13</a:t>
+              <a:t>5/25/2026</a:t>
             </a:fld>
             <a:endParaRPr lang="en-US"/>
           </a:p>
@@ -1395,7 +1399,7 @@
           <a:p>
             <a:fld id="{C1FF6DA9-008F-8B48-92A6-B652298478BF}" type="slidenum">
               <a:rPr lang="en-US" smtClean="0"/>
-              <a:t>‹#›</a:t>
+              <a:t>‹Nº›</a:t>
             </a:fld>
             <a:endParaRPr lang="en-US"/>
           </a:p>
@@ -1451,10 +1455,9 @@
           </a:lstStyle>
           <a:p>
             <a:r>
-              <a:rPr lang="en-US" smtClean="0"/>
+              <a:rPr lang="en-US"/>
               <a:t>Click to edit Master title style</a:t>
             </a:r>
-            <a:endParaRPr lang="en-US"/>
           </a:p>
         </p:txBody>
       </p:sp>
@@ -1517,7 +1520,7 @@
           <a:p>
             <a:pPr lvl="0"/>
             <a:r>
-              <a:rPr lang="en-US" smtClean="0"/>
+              <a:rPr lang="en-US"/>
               <a:t>Click to edit Master text styles</a:t>
             </a:r>
           </a:p>
@@ -1573,38 +1576,37 @@
           <a:p>
             <a:pPr lvl="0"/>
             <a:r>
-              <a:rPr lang="en-US" smtClean="0"/>
+              <a:rPr lang="en-US"/>
               <a:t>Click to edit Master text styles</a:t>
             </a:r>
           </a:p>
           <a:p>
             <a:pPr lvl="1"/>
             <a:r>
-              <a:rPr lang="en-US" smtClean="0"/>
+              <a:rPr lang="en-US"/>
               <a:t>Second level</a:t>
             </a:r>
           </a:p>
           <a:p>
             <a:pPr lvl="2"/>
             <a:r>
-              <a:rPr lang="en-US" smtClean="0"/>
+              <a:rPr lang="en-US"/>
               <a:t>Third level</a:t>
             </a:r>
           </a:p>
           <a:p>
             <a:pPr lvl="3"/>
             <a:r>
-              <a:rPr lang="en-US" smtClean="0"/>
+              <a:rPr lang="en-US"/>
               <a:t>Fourth level</a:t>
             </a:r>
           </a:p>
           <a:p>
             <a:pPr lvl="4"/>
             <a:r>
-              <a:rPr lang="en-US" smtClean="0"/>
+              <a:rPr lang="en-US"/>
               <a:t>Fifth level</a:t>
             </a:r>
-            <a:endParaRPr lang="en-US"/>
           </a:p>
         </p:txBody>
       </p:sp>
@@ -1667,7 +1669,7 @@
           <a:p>
             <a:pPr lvl="0"/>
             <a:r>
-              <a:rPr lang="en-US" smtClean="0"/>
+              <a:rPr lang="en-US"/>
               <a:t>Click to edit Master text styles</a:t>
             </a:r>
           </a:p>
@@ -1723,38 +1725,37 @@
           <a:p>
             <a:pPr lvl="0"/>
             <a:r>
-              <a:rPr lang="en-US" smtClean="0"/>
+              <a:rPr lang="en-US"/>
               <a:t>Click to edit Master text styles</a:t>
             </a:r>
           </a:p>
           <a:p>
             <a:pPr lvl="1"/>
             <a:r>
-              <a:rPr lang="en-US" smtClean="0"/>
+              <a:rPr lang="en-US"/>
               <a:t>Second level</a:t>
             </a:r>
           </a:p>
           <a:p>
             <a:pPr lvl="2"/>
             <a:r>
-              <a:rPr lang="en-US" smtClean="0"/>
+              <a:rPr lang="en-US"/>
               <a:t>Third level</a:t>
             </a:r>
           </a:p>
           <a:p>
             <a:pPr lvl="3"/>
             <a:r>
-              <a:rPr lang="en-US" smtClean="0"/>
+              <a:rPr lang="en-US"/>
               <a:t>Fourth level</a:t>
             </a:r>
           </a:p>
           <a:p>
             <a:pPr lvl="4"/>
             <a:r>
-              <a:rPr lang="en-US" smtClean="0"/>
+              <a:rPr lang="en-US"/>
               <a:t>Fifth level</a:t>
             </a:r>
-            <a:endParaRPr lang="en-US"/>
           </a:p>
         </p:txBody>
       </p:sp>
@@ -1775,7 +1776,7 @@
           <a:p>
             <a:fld id="{5BCAD085-E8A6-8845-BD4E-CB4CCA059FC4}" type="datetimeFigureOut">
               <a:rPr lang="en-US" smtClean="0"/>
-              <a:t>1/27/13</a:t>
+              <a:t>5/25/2026</a:t>
             </a:fld>
             <a:endParaRPr lang="en-US"/>
           </a:p>
@@ -1817,7 +1818,7 @@
           <a:p>
             <a:fld id="{C1FF6DA9-008F-8B48-92A6-B652298478BF}" type="slidenum">
               <a:rPr lang="en-US" smtClean="0"/>
-              <a:t>‹#›</a:t>
+              <a:t>‹Nº›</a:t>
             </a:fld>
             <a:endParaRPr lang="en-US"/>
           </a:p>
@@ -1869,10 +1870,9 @@
           <a:lstStyle/>
           <a:p>
             <a:r>
-              <a:rPr lang="en-US" smtClean="0"/>
+              <a:rPr lang="en-US"/>
               <a:t>Click to edit Master title style</a:t>
             </a:r>
-            <a:endParaRPr lang="en-US"/>
           </a:p>
         </p:txBody>
       </p:sp>
@@ -1893,7 +1893,7 @@
           <a:p>
             <a:fld id="{5BCAD085-E8A6-8845-BD4E-CB4CCA059FC4}" type="datetimeFigureOut">
               <a:rPr lang="en-US" smtClean="0"/>
-              <a:t>1/27/13</a:t>
+              <a:t>5/25/2026</a:t>
             </a:fld>
             <a:endParaRPr lang="en-US"/>
           </a:p>
@@ -1935,7 +1935,7 @@
           <a:p>
             <a:fld id="{C1FF6DA9-008F-8B48-92A6-B652298478BF}" type="slidenum">
               <a:rPr lang="en-US" smtClean="0"/>
-              <a:t>‹#›</a:t>
+              <a:t>‹Nº›</a:t>
             </a:fld>
             <a:endParaRPr lang="en-US"/>
           </a:p>
@@ -1988,7 +1988,7 @@
           <a:p>
             <a:fld id="{5BCAD085-E8A6-8845-BD4E-CB4CCA059FC4}" type="datetimeFigureOut">
               <a:rPr lang="en-US" smtClean="0"/>
-              <a:t>1/27/13</a:t>
+              <a:t>5/25/2026</a:t>
             </a:fld>
             <a:endParaRPr lang="en-US"/>
           </a:p>
@@ -2030,7 +2030,7 @@
           <a:p>
             <a:fld id="{C1FF6DA9-008F-8B48-92A6-B652298478BF}" type="slidenum">
               <a:rPr lang="en-US" smtClean="0"/>
-              <a:t>‹#›</a:t>
+              <a:t>‹Nº›</a:t>
             </a:fld>
             <a:endParaRPr lang="en-US"/>
           </a:p>
@@ -2091,10 +2091,9 @@
           </a:lstStyle>
           <a:p>
             <a:r>
-              <a:rPr lang="en-US" smtClean="0"/>
+              <a:rPr lang="en-US"/>
               <a:t>Click to edit Master title style</a:t>
             </a:r>
-            <a:endParaRPr lang="en-US"/>
           </a:p>
         </p:txBody>
       </p:sp>
@@ -2148,38 +2147,37 @@
           <a:p>
             <a:pPr lvl="0"/>
             <a:r>
-              <a:rPr lang="en-US" smtClean="0"/>
+              <a:rPr lang="en-US"/>
               <a:t>Click to edit Master text styles</a:t>
             </a:r>
           </a:p>
           <a:p>
             <a:pPr lvl="1"/>
             <a:r>
-              <a:rPr lang="en-US" smtClean="0"/>
+              <a:rPr lang="en-US"/>
               <a:t>Second level</a:t>
             </a:r>
           </a:p>
           <a:p>
             <a:pPr lvl="2"/>
             <a:r>
-              <a:rPr lang="en-US" smtClean="0"/>
+              <a:rPr lang="en-US"/>
               <a:t>Third level</a:t>
             </a:r>
           </a:p>
           <a:p>
             <a:pPr lvl="3"/>
             <a:r>
-              <a:rPr lang="en-US" smtClean="0"/>
+              <a:rPr lang="en-US"/>
               <a:t>Fourth level</a:t>
             </a:r>
           </a:p>
           <a:p>
             <a:pPr lvl="4"/>
             <a:r>
-              <a:rPr lang="en-US" smtClean="0"/>
+              <a:rPr lang="en-US"/>
               <a:t>Fifth level</a:t>
             </a:r>
-            <a:endParaRPr lang="en-US"/>
           </a:p>
         </p:txBody>
       </p:sp>
@@ -2242,7 +2240,7 @@
           <a:p>
             <a:pPr lvl="0"/>
             <a:r>
-              <a:rPr lang="en-US" smtClean="0"/>
+              <a:rPr lang="en-US"/>
               <a:t>Click to edit Master text styles</a:t>
             </a:r>
           </a:p>
@@ -2265,7 +2263,7 @@
           <a:p>
             <a:fld id="{5BCAD085-E8A6-8845-BD4E-CB4CCA059FC4}" type="datetimeFigureOut">
               <a:rPr lang="en-US" smtClean="0"/>
-              <a:t>1/27/13</a:t>
+              <a:t>5/25/2026</a:t>
             </a:fld>
             <a:endParaRPr lang="en-US"/>
           </a:p>
@@ -2307,7 +2305,7 @@
           <a:p>
             <a:fld id="{C1FF6DA9-008F-8B48-92A6-B652298478BF}" type="slidenum">
               <a:rPr lang="en-US" smtClean="0"/>
-              <a:t>‹#›</a:t>
+              <a:t>‹Nº›</a:t>
             </a:fld>
             <a:endParaRPr lang="en-US"/>
           </a:p>
@@ -2368,10 +2366,9 @@
           </a:lstStyle>
           <a:p>
             <a:r>
-              <a:rPr lang="en-US" smtClean="0"/>
+              <a:rPr lang="en-US"/>
               <a:t>Click to edit Master title style</a:t>
             </a:r>
-            <a:endParaRPr lang="en-US"/>
           </a:p>
         </p:txBody>
       </p:sp>
@@ -2495,7 +2492,7 @@
           <a:p>
             <a:pPr lvl="0"/>
             <a:r>
-              <a:rPr lang="en-US" smtClean="0"/>
+              <a:rPr lang="en-US"/>
               <a:t>Click to edit Master text styles</a:t>
             </a:r>
           </a:p>
@@ -2518,7 +2515,7 @@
           <a:p>
             <a:fld id="{5BCAD085-E8A6-8845-BD4E-CB4CCA059FC4}" type="datetimeFigureOut">
               <a:rPr lang="en-US" smtClean="0"/>
-              <a:t>1/27/13</a:t>
+              <a:t>5/25/2026</a:t>
             </a:fld>
             <a:endParaRPr lang="en-US"/>
           </a:p>
@@ -2560,7 +2557,7 @@
           <a:p>
             <a:fld id="{C1FF6DA9-008F-8B48-92A6-B652298478BF}" type="slidenum">
               <a:rPr lang="en-US" smtClean="0"/>
-              <a:t>‹#›</a:t>
+              <a:t>‹Nº›</a:t>
             </a:fld>
             <a:endParaRPr lang="en-US"/>
           </a:p>
@@ -2627,10 +2624,9 @@
           <a:lstStyle/>
           <a:p>
             <a:r>
-              <a:rPr lang="en-US" smtClean="0"/>
+              <a:rPr lang="en-US"/>
               <a:t>Click to edit Master title style</a:t>
             </a:r>
-            <a:endParaRPr lang="en-US"/>
           </a:p>
         </p:txBody>
       </p:sp>
@@ -2661,38 +2657,37 @@
           <a:p>
             <a:pPr lvl="0"/>
             <a:r>
-              <a:rPr lang="en-US" smtClean="0"/>
+              <a:rPr lang="en-US"/>
               <a:t>Click to edit Master text styles</a:t>
             </a:r>
           </a:p>
           <a:p>
             <a:pPr lvl="1"/>
             <a:r>
-              <a:rPr lang="en-US" smtClean="0"/>
+              <a:rPr lang="en-US"/>
               <a:t>Second level</a:t>
             </a:r>
           </a:p>
           <a:p>
             <a:pPr lvl="2"/>
             <a:r>
-              <a:rPr lang="en-US" smtClean="0"/>
+              <a:rPr lang="en-US"/>
               <a:t>Third level</a:t>
             </a:r>
           </a:p>
           <a:p>
             <a:pPr lvl="3"/>
             <a:r>
-              <a:rPr lang="en-US" smtClean="0"/>
+              <a:rPr lang="en-US"/>
               <a:t>Fourth level</a:t>
             </a:r>
           </a:p>
           <a:p>
             <a:pPr lvl="4"/>
             <a:r>
-              <a:rPr lang="en-US" smtClean="0"/>
+              <a:rPr lang="en-US"/>
               <a:t>Fifth level</a:t>
             </a:r>
-            <a:endParaRPr lang="en-US"/>
           </a:p>
         </p:txBody>
       </p:sp>
@@ -2731,7 +2726,7 @@
           <a:p>
             <a:fld id="{5BCAD085-E8A6-8845-BD4E-CB4CCA059FC4}" type="datetimeFigureOut">
               <a:rPr lang="en-US" smtClean="0"/>
-              <a:t>1/27/13</a:t>
+              <a:t>5/25/2026</a:t>
             </a:fld>
             <a:endParaRPr lang="en-US"/>
           </a:p>
@@ -2809,7 +2804,7 @@
           <a:p>
             <a:fld id="{C1FF6DA9-008F-8B48-92A6-B652298478BF}" type="slidenum">
               <a:rPr lang="en-US" smtClean="0"/>
-              <a:t>‹#›</a:t>
+              <a:t>‹Nº›</a:t>
             </a:fld>
             <a:endParaRPr lang="en-US"/>
           </a:p>
@@ -3090,7 +3085,7 @@
 </file>
 
 <file path=ppt/slides/slide1.xml><?xml version="1.0" encoding="utf-8"?>
-<p:sld xmlns:a="http://schemas.openxmlformats.org/drawingml/2006/main" xmlns:p="http://schemas.openxmlformats.org/presentationml/2006/main" xmlns:r="http://schemas.openxmlformats.org/officeDocument/2006/relationships">
+<p:sld xmlns:a="http://schemas.openxmlformats.org/drawingml/2006/main" xmlns:r="http://schemas.openxmlformats.org/officeDocument/2006/relationships" xmlns:p="http://schemas.openxmlformats.org/presentationml/2006/main">
   <p:cSld>
     <p:bg>
       <p:bgPr>
@@ -3106,7 +3101,14 @@
         <p:cNvGrpSpPr/>
         <p:nvPr/>
       </p:nvGrpSpPr>
-      <p:grpSpPr/>
+      <p:grpSpPr>
+        <a:xfrm>
+          <a:off x="0" y="0"/>
+          <a:ext cx="0" cy="0"/>
+          <a:chOff x="0" y="0"/>
+          <a:chExt cx="0" cy="0"/>
+        </a:xfrm>
+      </p:grpSpPr>
       <p:sp>
         <p:nvSpPr>
           <p:cNvPr id="2" name="Rectangle 1"/>
@@ -3147,6 +3149,7 @@
           <a:lstStyle/>
           <a:p>
             <a:pPr algn="ctr"/>
+            <a:endParaRPr/>
           </a:p>
         </p:txBody>
       </p:sp>
@@ -3190,6 +3193,7 @@
           <a:lstStyle/>
           <a:p>
             <a:pPr algn="ctr"/>
+            <a:endParaRPr/>
           </a:p>
         </p:txBody>
       </p:sp>
@@ -3233,6 +3237,7 @@
           <a:lstStyle/>
           <a:p>
             <a:pPr algn="ctr"/>
+            <a:endParaRPr/>
           </a:p>
         </p:txBody>
       </p:sp>
@@ -3278,6 +3283,7 @@
           <a:lstStyle/>
           <a:p>
             <a:pPr algn="ctr"/>
+            <a:endParaRPr/>
           </a:p>
         </p:txBody>
       </p:sp>
@@ -3302,7 +3308,9 @@
             <a:spAutoFit/>
           </a:bodyPr>
           <a:lstStyle/>
-          <a:p/>
+          <a:p>
+            <a:endParaRPr dirty="0"/>
+          </a:p>
           <a:p>
             <a:pPr algn="l">
               <a:spcBef>
@@ -3318,6 +3326,7 @@
               </a:defRPr>
             </a:pPr>
             <a:r>
+              <a:rPr dirty="0"/>
               <a:t>PONENCIA DE TESIS DE GRADO EN INGENIERÍA DE SISTEMAS</a:t>
             </a:r>
           </a:p>
@@ -3336,7 +3345,16 @@
               </a:defRPr>
             </a:pPr>
             <a:r>
-              <a:t>Universidad · Facultad de Ingeniería · Carrera de Ingeniería de Sistemas</a:t>
+              <a:rPr dirty="0"/>
+              <a:t>Universidad · </a:t>
+            </a:r>
+            <a:r>
+              <a:rPr dirty="0" err="1"/>
+              <a:t>Facultad</a:t>
+            </a:r>
+            <a:r>
+              <a:rPr dirty="0"/>
+              <a:t> de Ingeniería · Carrera de Ingeniería de Sistemas</a:t>
             </a:r>
           </a:p>
           <a:p>
@@ -3354,6 +3372,7 @@
               </a:defRPr>
             </a:pPr>
             <a:r>
+              <a:rPr dirty="0"/>
               <a:t>────────────────────────────────────────────────────────────────────</a:t>
             </a:r>
           </a:p>
@@ -3372,8 +3391,22 @@
               </a:defRPr>
             </a:pPr>
             <a:r>
-              <a:t>Desarrollo de un Sistema Web de Traducción Automática</a:t>
-            </a:r>
+              <a:rPr dirty="0"/>
+              <a:t>Desarrollo de un Sistema Web de </a:t>
+            </a:r>
+            <a:r>
+              <a:rPr dirty="0" err="1"/>
+              <a:t>Traducción</a:t>
+            </a:r>
+            <a:r>
+              <a:rPr dirty="0"/>
+              <a:t> </a:t>
+            </a:r>
+            <a:r>
+              <a:rPr dirty="0" err="1"/>
+              <a:t>Automática</a:t>
+            </a:r>
+            <a:endParaRPr dirty="0"/>
           </a:p>
           <a:p>
             <a:pPr algn="l">
@@ -3390,7 +3423,16 @@
               </a:defRPr>
             </a:pPr>
             <a:r>
-              <a:t>Neuronal Bidireccional Español ⇄ Aimara</a:t>
+              <a:rPr dirty="0"/>
+              <a:t>Neuronal </a:t>
+            </a:r>
+            <a:r>
+              <a:rPr dirty="0" err="1"/>
+              <a:t>Bidireccional</a:t>
+            </a:r>
+            <a:r>
+              <a:rPr dirty="0"/>
+              <a:t> Español ⇄ Aimara</a:t>
             </a:r>
           </a:p>
           <a:p>
@@ -3408,7 +3450,24 @@
               </a:defRPr>
             </a:pPr>
             <a:r>
-              <a:t>con Inferencia Speech-to-Speech en Tiempo Real</a:t>
+              <a:rPr dirty="0"/>
+              <a:t>con </a:t>
+            </a:r>
+            <a:r>
+              <a:rPr dirty="0" err="1"/>
+              <a:t>Inferencia</a:t>
+            </a:r>
+            <a:r>
+              <a:rPr dirty="0"/>
+              <a:t> Speech-to-Speech </a:t>
+            </a:r>
+            <a:r>
+              <a:rPr dirty="0" err="1"/>
+              <a:t>en</a:t>
+            </a:r>
+            <a:r>
+              <a:rPr dirty="0"/>
+              <a:t> Tiempo Real</a:t>
             </a:r>
           </a:p>
           <a:p>
@@ -3426,6 +3485,7 @@
               </a:defRPr>
             </a:pPr>
             <a:r>
+              <a:rPr dirty="0"/>
               <a:t>────────────────────────────────────────────────────────────────────</a:t>
             </a:r>
           </a:p>
@@ -3444,7 +3504,20 @@
               </a:defRPr>
             </a:pPr>
             <a:r>
-              <a:t>Modelos: OpenAI Whisper Large V3 Turbo  ·  Meta NLLB-200-distilled-600M + LoRA PEFT  ·  Meta MMS VITS (TTS)</a:t>
+              <a:rPr dirty="0" err="1"/>
+              <a:t>Modelos</a:t>
+            </a:r>
+            <a:r>
+              <a:rPr dirty="0"/>
+              <a:t>: OpenAI Whisper Large V3 Turbo  ·  Meta NLLB-200-distilled-600M + </a:t>
+            </a:r>
+            <a:r>
+              <a:rPr dirty="0" err="1"/>
+              <a:t>LoRA</a:t>
+            </a:r>
+            <a:r>
+              <a:rPr dirty="0"/>
+              <a:t> PEFT  ·  Meta MMS VITS (TTS)</a:t>
             </a:r>
           </a:p>
           <a:p>
@@ -3462,7 +3535,28 @@
               </a:defRPr>
             </a:pPr>
             <a:r>
-              <a:t>Infraestructura: Python (FastAPI 0.115)  ·  PHP (Laravel 11)  ·  PyTorch 2.x  ·  GPU NVIDIA RTX 5060 (8 GB VRAM)</a:t>
+              <a:rPr dirty="0" err="1"/>
+              <a:t>Infraestructura</a:t>
+            </a:r>
+            <a:r>
+              <a:rPr dirty="0"/>
+              <a:t>: Python (</a:t>
+            </a:r>
+            <a:r>
+              <a:rPr dirty="0" err="1"/>
+              <a:t>FastAPI</a:t>
+            </a:r>
+            <a:r>
+              <a:rPr dirty="0"/>
+              <a:t> 0.115)  ·  PHP (Laravel 11)  ·  </a:t>
+            </a:r>
+            <a:r>
+              <a:rPr dirty="0" err="1"/>
+              <a:t>PyTorch</a:t>
+            </a:r>
+            <a:r>
+              <a:rPr dirty="0"/>
+              <a:t> 2.x  ·  GPU NVIDIA RTX 5060 (8 GB VRAM)</a:t>
             </a:r>
           </a:p>
           <a:p>
@@ -3480,6 +3574,7 @@
               </a:defRPr>
             </a:pPr>
             <a:r>
+              <a:rPr dirty="0"/>
               <a:t>Mayo 2026</a:t>
             </a:r>
           </a:p>
@@ -3494,7 +3589,7 @@
 </file>
 
 <file path=ppt/slides/slide10.xml><?xml version="1.0" encoding="utf-8"?>
-<p:sld xmlns:a="http://schemas.openxmlformats.org/drawingml/2006/main" xmlns:p="http://schemas.openxmlformats.org/presentationml/2006/main" xmlns:r="http://schemas.openxmlformats.org/officeDocument/2006/relationships">
+<p:sld xmlns:a="http://schemas.openxmlformats.org/drawingml/2006/main" xmlns:r="http://schemas.openxmlformats.org/officeDocument/2006/relationships" xmlns:p="http://schemas.openxmlformats.org/presentationml/2006/main">
   <p:cSld>
     <p:bg>
       <p:bgPr>
@@ -3510,7 +3605,14 @@
         <p:cNvGrpSpPr/>
         <p:nvPr/>
       </p:nvGrpSpPr>
-      <p:grpSpPr/>
+      <p:grpSpPr>
+        <a:xfrm>
+          <a:off x="0" y="0"/>
+          <a:ext cx="0" cy="0"/>
+          <a:chOff x="0" y="0"/>
+          <a:chExt cx="0" cy="0"/>
+        </a:xfrm>
+      </p:grpSpPr>
       <p:sp>
         <p:nvSpPr>
           <p:cNvPr id="2" name="Rectangle 1"/>
@@ -3551,6 +3653,7 @@
           <a:lstStyle/>
           <a:p>
             <a:pPr algn="ctr"/>
+            <a:endParaRPr/>
           </a:p>
         </p:txBody>
       </p:sp>
@@ -3594,6 +3697,7 @@
           <a:lstStyle/>
           <a:p>
             <a:pPr algn="ctr"/>
+            <a:endParaRPr/>
           </a:p>
         </p:txBody>
       </p:sp>
@@ -3618,7 +3722,9 @@
             <a:spAutoFit/>
           </a:bodyPr>
           <a:lstStyle/>
-          <a:p/>
+          <a:p>
+            <a:endParaRPr/>
+          </a:p>
           <a:p>
             <a:pPr algn="r">
               <a:spcBef>
@@ -3660,7 +3766,9 @@
             <a:spAutoFit/>
           </a:bodyPr>
           <a:lstStyle/>
-          <a:p/>
+          <a:p>
+            <a:endParaRPr/>
+          </a:p>
           <a:p>
             <a:pPr algn="l">
               <a:spcBef>
@@ -3789,6 +3897,7 @@
           <a:lstStyle/>
           <a:p>
             <a:pPr algn="ctr"/>
+            <a:endParaRPr/>
           </a:p>
         </p:txBody>
       </p:sp>
@@ -3813,7 +3922,9 @@
             <a:spAutoFit/>
           </a:bodyPr>
           <a:lstStyle/>
-          <a:p/>
+          <a:p>
+            <a:endParaRPr/>
+          </a:p>
           <a:p>
             <a:pPr algn="l">
               <a:spcBef>
@@ -3894,6 +4005,7 @@
           <a:lstStyle/>
           <a:p>
             <a:pPr algn="ctr"/>
+            <a:endParaRPr/>
           </a:p>
         </p:txBody>
       </p:sp>
@@ -3918,7 +4030,9 @@
             <a:spAutoFit/>
           </a:bodyPr>
           <a:lstStyle/>
-          <a:p/>
+          <a:p>
+            <a:endParaRPr/>
+          </a:p>
           <a:p>
             <a:pPr algn="l">
               <a:spcBef>
@@ -3966,7 +4080,7 @@
 </file>
 
 <file path=ppt/slides/slide11.xml><?xml version="1.0" encoding="utf-8"?>
-<p:sld xmlns:a="http://schemas.openxmlformats.org/drawingml/2006/main" xmlns:p="http://schemas.openxmlformats.org/presentationml/2006/main" xmlns:r="http://schemas.openxmlformats.org/officeDocument/2006/relationships">
+<p:sld xmlns:a="http://schemas.openxmlformats.org/drawingml/2006/main" xmlns:r="http://schemas.openxmlformats.org/officeDocument/2006/relationships" xmlns:p="http://schemas.openxmlformats.org/presentationml/2006/main">
   <p:cSld>
     <p:bg>
       <p:bgPr>
@@ -3982,7 +4096,14 @@
         <p:cNvGrpSpPr/>
         <p:nvPr/>
       </p:nvGrpSpPr>
-      <p:grpSpPr/>
+      <p:grpSpPr>
+        <a:xfrm>
+          <a:off x="0" y="0"/>
+          <a:ext cx="0" cy="0"/>
+          <a:chOff x="0" y="0"/>
+          <a:chExt cx="0" cy="0"/>
+        </a:xfrm>
+      </p:grpSpPr>
       <p:sp>
         <p:nvSpPr>
           <p:cNvPr id="2" name="Rectangle 1"/>
@@ -4023,6 +4144,7 @@
           <a:lstStyle/>
           <a:p>
             <a:pPr algn="ctr"/>
+            <a:endParaRPr/>
           </a:p>
         </p:txBody>
       </p:sp>
@@ -4066,6 +4188,7 @@
           <a:lstStyle/>
           <a:p>
             <a:pPr algn="ctr"/>
+            <a:endParaRPr/>
           </a:p>
         </p:txBody>
       </p:sp>
@@ -4090,7 +4213,9 @@
             <a:spAutoFit/>
           </a:bodyPr>
           <a:lstStyle/>
-          <a:p/>
+          <a:p>
+            <a:endParaRPr/>
+          </a:p>
           <a:p>
             <a:pPr algn="r">
               <a:spcBef>
@@ -4132,7 +4257,9 @@
             <a:spAutoFit/>
           </a:bodyPr>
           <a:lstStyle/>
-          <a:p/>
+          <a:p>
+            <a:endParaRPr/>
+          </a:p>
           <a:p>
             <a:pPr algn="l">
               <a:spcBef>
@@ -4213,6 +4340,7 @@
           <a:lstStyle/>
           <a:p>
             <a:pPr algn="ctr"/>
+            <a:endParaRPr/>
           </a:p>
         </p:txBody>
       </p:sp>
@@ -4237,7 +4365,9 @@
             <a:spAutoFit/>
           </a:bodyPr>
           <a:lstStyle/>
-          <a:p/>
+          <a:p>
+            <a:endParaRPr/>
+          </a:p>
           <a:p>
             <a:pPr algn="l">
               <a:spcBef>
@@ -4318,6 +4448,7 @@
           <a:lstStyle/>
           <a:p>
             <a:pPr algn="ctr"/>
+            <a:endParaRPr/>
           </a:p>
         </p:txBody>
       </p:sp>
@@ -4342,7 +4473,9 @@
             <a:spAutoFit/>
           </a:bodyPr>
           <a:lstStyle/>
-          <a:p/>
+          <a:p>
+            <a:endParaRPr/>
+          </a:p>
           <a:p>
             <a:pPr algn="l">
               <a:spcBef>
@@ -4423,6 +4556,7 @@
           <a:lstStyle/>
           <a:p>
             <a:pPr algn="ctr"/>
+            <a:endParaRPr/>
           </a:p>
         </p:txBody>
       </p:sp>
@@ -4447,7 +4581,9 @@
             <a:spAutoFit/>
           </a:bodyPr>
           <a:lstStyle/>
-          <a:p/>
+          <a:p>
+            <a:endParaRPr/>
+          </a:p>
           <a:p>
             <a:pPr algn="l">
               <a:spcBef>
@@ -4528,6 +4664,7 @@
           <a:lstStyle/>
           <a:p>
             <a:pPr algn="ctr"/>
+            <a:endParaRPr/>
           </a:p>
         </p:txBody>
       </p:sp>
@@ -4552,7 +4689,9 @@
             <a:spAutoFit/>
           </a:bodyPr>
           <a:lstStyle/>
-          <a:p/>
+          <a:p>
+            <a:endParaRPr/>
+          </a:p>
           <a:p>
             <a:pPr algn="l">
               <a:spcBef>
@@ -4600,7 +4739,7 @@
 </file>
 
 <file path=ppt/slides/slide12.xml><?xml version="1.0" encoding="utf-8"?>
-<p:sld xmlns:a="http://schemas.openxmlformats.org/drawingml/2006/main" xmlns:p="http://schemas.openxmlformats.org/presentationml/2006/main" xmlns:r="http://schemas.openxmlformats.org/officeDocument/2006/relationships">
+<p:sld xmlns:a="http://schemas.openxmlformats.org/drawingml/2006/main" xmlns:r="http://schemas.openxmlformats.org/officeDocument/2006/relationships" xmlns:p="http://schemas.openxmlformats.org/presentationml/2006/main">
   <p:cSld>
     <p:bg>
       <p:bgPr>
@@ -4616,7 +4755,14 @@
         <p:cNvGrpSpPr/>
         <p:nvPr/>
       </p:nvGrpSpPr>
-      <p:grpSpPr/>
+      <p:grpSpPr>
+        <a:xfrm>
+          <a:off x="0" y="0"/>
+          <a:ext cx="0" cy="0"/>
+          <a:chOff x="0" y="0"/>
+          <a:chExt cx="0" cy="0"/>
+        </a:xfrm>
+      </p:grpSpPr>
       <p:sp>
         <p:nvSpPr>
           <p:cNvPr id="2" name="Rectangle 1"/>
@@ -4657,6 +4803,7 @@
           <a:lstStyle/>
           <a:p>
             <a:pPr algn="ctr"/>
+            <a:endParaRPr/>
           </a:p>
         </p:txBody>
       </p:sp>
@@ -4700,6 +4847,7 @@
           <a:lstStyle/>
           <a:p>
             <a:pPr algn="ctr"/>
+            <a:endParaRPr/>
           </a:p>
         </p:txBody>
       </p:sp>
@@ -4724,7 +4872,9 @@
             <a:spAutoFit/>
           </a:bodyPr>
           <a:lstStyle/>
-          <a:p/>
+          <a:p>
+            <a:endParaRPr/>
+          </a:p>
           <a:p>
             <a:pPr algn="r">
               <a:spcBef>
@@ -4766,7 +4916,9 @@
             <a:spAutoFit/>
           </a:bodyPr>
           <a:lstStyle/>
-          <a:p/>
+          <a:p>
+            <a:endParaRPr/>
+          </a:p>
           <a:p>
             <a:pPr algn="l">
               <a:spcBef>
@@ -4871,6 +5023,7 @@
           <a:lstStyle/>
           <a:p>
             <a:pPr algn="ctr"/>
+            <a:endParaRPr/>
           </a:p>
         </p:txBody>
       </p:sp>
@@ -4895,7 +5048,9 @@
             <a:spAutoFit/>
           </a:bodyPr>
           <a:lstStyle/>
-          <a:p/>
+          <a:p>
+            <a:endParaRPr/>
+          </a:p>
           <a:p>
             <a:pPr algn="l">
               <a:spcBef>
@@ -5012,6 +5167,7 @@
           <a:lstStyle/>
           <a:p>
             <a:pPr algn="ctr"/>
+            <a:endParaRPr/>
           </a:p>
         </p:txBody>
       </p:sp>
@@ -5036,7 +5192,9 @@
             <a:spAutoFit/>
           </a:bodyPr>
           <a:lstStyle/>
-          <a:p/>
+          <a:p>
+            <a:endParaRPr/>
+          </a:p>
           <a:p>
             <a:pPr algn="l">
               <a:spcBef>
@@ -5117,6 +5275,7 @@
           <a:lstStyle/>
           <a:p>
             <a:pPr algn="ctr"/>
+            <a:endParaRPr/>
           </a:p>
         </p:txBody>
       </p:sp>
@@ -5141,7 +5300,9 @@
             <a:spAutoFit/>
           </a:bodyPr>
           <a:lstStyle/>
-          <a:p/>
+          <a:p>
+            <a:endParaRPr/>
+          </a:p>
           <a:p>
             <a:pPr algn="l">
               <a:spcBef>
@@ -5189,7 +5350,7 @@
 </file>
 
 <file path=ppt/slides/slide2.xml><?xml version="1.0" encoding="utf-8"?>
-<p:sld xmlns:a="http://schemas.openxmlformats.org/drawingml/2006/main" xmlns:p="http://schemas.openxmlformats.org/presentationml/2006/main" xmlns:r="http://schemas.openxmlformats.org/officeDocument/2006/relationships">
+<p:sld xmlns:a="http://schemas.openxmlformats.org/drawingml/2006/main" xmlns:r="http://schemas.openxmlformats.org/officeDocument/2006/relationships" xmlns:p="http://schemas.openxmlformats.org/presentationml/2006/main">
   <p:cSld>
     <p:bg>
       <p:bgPr>
@@ -5205,7 +5366,14 @@
         <p:cNvGrpSpPr/>
         <p:nvPr/>
       </p:nvGrpSpPr>
-      <p:grpSpPr/>
+      <p:grpSpPr>
+        <a:xfrm>
+          <a:off x="0" y="0"/>
+          <a:ext cx="0" cy="0"/>
+          <a:chOff x="0" y="0"/>
+          <a:chExt cx="0" cy="0"/>
+        </a:xfrm>
+      </p:grpSpPr>
       <p:sp>
         <p:nvSpPr>
           <p:cNvPr id="2" name="Rectangle 1"/>
@@ -5246,6 +5414,7 @@
           <a:lstStyle/>
           <a:p>
             <a:pPr algn="ctr"/>
+            <a:endParaRPr/>
           </a:p>
         </p:txBody>
       </p:sp>
@@ -5289,6 +5458,7 @@
           <a:lstStyle/>
           <a:p>
             <a:pPr algn="ctr"/>
+            <a:endParaRPr/>
           </a:p>
         </p:txBody>
       </p:sp>
@@ -5313,7 +5483,9 @@
             <a:spAutoFit/>
           </a:bodyPr>
           <a:lstStyle/>
-          <a:p/>
+          <a:p>
+            <a:endParaRPr/>
+          </a:p>
           <a:p>
             <a:pPr algn="r">
               <a:spcBef>
@@ -5355,7 +5527,9 @@
             <a:spAutoFit/>
           </a:bodyPr>
           <a:lstStyle/>
-          <a:p/>
+          <a:p>
+            <a:endParaRPr/>
+          </a:p>
           <a:p>
             <a:pPr algn="l">
               <a:spcBef>
@@ -5436,6 +5610,7 @@
           <a:lstStyle/>
           <a:p>
             <a:pPr algn="ctr"/>
+            <a:endParaRPr/>
           </a:p>
         </p:txBody>
       </p:sp>
@@ -5460,7 +5635,9 @@
             <a:spAutoFit/>
           </a:bodyPr>
           <a:lstStyle/>
-          <a:p/>
+          <a:p>
+            <a:endParaRPr/>
+          </a:p>
           <a:p>
             <a:pPr algn="l">
               <a:spcBef>
@@ -5649,6 +5826,7 @@
           <a:lstStyle/>
           <a:p>
             <a:pPr algn="ctr"/>
+            <a:endParaRPr/>
           </a:p>
         </p:txBody>
       </p:sp>
@@ -5673,7 +5851,9 @@
             <a:spAutoFit/>
           </a:bodyPr>
           <a:lstStyle/>
-          <a:p/>
+          <a:p>
+            <a:endParaRPr/>
+          </a:p>
           <a:p>
             <a:pPr algn="l">
               <a:spcBef>
@@ -5829,7 +6009,7 @@
 </file>
 
 <file path=ppt/slides/slide3.xml><?xml version="1.0" encoding="utf-8"?>
-<p:sld xmlns:a="http://schemas.openxmlformats.org/drawingml/2006/main" xmlns:p="http://schemas.openxmlformats.org/presentationml/2006/main" xmlns:r="http://schemas.openxmlformats.org/officeDocument/2006/relationships">
+<p:sld xmlns:a="http://schemas.openxmlformats.org/drawingml/2006/main" xmlns:r="http://schemas.openxmlformats.org/officeDocument/2006/relationships" xmlns:p="http://schemas.openxmlformats.org/presentationml/2006/main">
   <p:cSld>
     <p:bg>
       <p:bgPr>
@@ -5845,7 +6025,14 @@
         <p:cNvGrpSpPr/>
         <p:nvPr/>
       </p:nvGrpSpPr>
-      <p:grpSpPr/>
+      <p:grpSpPr>
+        <a:xfrm>
+          <a:off x="0" y="0"/>
+          <a:ext cx="0" cy="0"/>
+          <a:chOff x="0" y="0"/>
+          <a:chExt cx="0" cy="0"/>
+        </a:xfrm>
+      </p:grpSpPr>
       <p:sp>
         <p:nvSpPr>
           <p:cNvPr id="2" name="Rectangle 1"/>
@@ -5886,6 +6073,7 @@
           <a:lstStyle/>
           <a:p>
             <a:pPr algn="ctr"/>
+            <a:endParaRPr/>
           </a:p>
         </p:txBody>
       </p:sp>
@@ -5929,6 +6117,7 @@
           <a:lstStyle/>
           <a:p>
             <a:pPr algn="ctr"/>
+            <a:endParaRPr/>
           </a:p>
         </p:txBody>
       </p:sp>
@@ -5953,7 +6142,9 @@
             <a:spAutoFit/>
           </a:bodyPr>
           <a:lstStyle/>
-          <a:p/>
+          <a:p>
+            <a:endParaRPr/>
+          </a:p>
           <a:p>
             <a:pPr algn="r">
               <a:spcBef>
@@ -5995,7 +6186,9 @@
             <a:spAutoFit/>
           </a:bodyPr>
           <a:lstStyle/>
-          <a:p/>
+          <a:p>
+            <a:endParaRPr/>
+          </a:p>
           <a:p>
             <a:pPr algn="l">
               <a:spcBef>
@@ -6076,6 +6269,7 @@
           <a:lstStyle/>
           <a:p>
             <a:pPr algn="ctr"/>
+            <a:endParaRPr/>
           </a:p>
         </p:txBody>
       </p:sp>
@@ -6100,7 +6294,9 @@
             <a:spAutoFit/>
           </a:bodyPr>
           <a:lstStyle/>
-          <a:p/>
+          <a:p>
+            <a:endParaRPr/>
+          </a:p>
           <a:p>
             <a:pPr algn="l">
               <a:spcBef>
@@ -6325,6 +6521,7 @@
           <a:lstStyle/>
           <a:p>
             <a:pPr algn="ctr"/>
+            <a:endParaRPr/>
           </a:p>
         </p:txBody>
       </p:sp>
@@ -6349,7 +6546,9 @@
             <a:spAutoFit/>
           </a:bodyPr>
           <a:lstStyle/>
-          <a:p/>
+          <a:p>
+            <a:endParaRPr/>
+          </a:p>
           <a:p>
             <a:pPr algn="l">
               <a:spcBef>
@@ -6523,7 +6722,7 @@
 </file>
 
 <file path=ppt/slides/slide4.xml><?xml version="1.0" encoding="utf-8"?>
-<p:sld xmlns:a="http://schemas.openxmlformats.org/drawingml/2006/main" xmlns:p="http://schemas.openxmlformats.org/presentationml/2006/main" xmlns:r="http://schemas.openxmlformats.org/officeDocument/2006/relationships">
+<p:sld xmlns:a="http://schemas.openxmlformats.org/drawingml/2006/main" xmlns:r="http://schemas.openxmlformats.org/officeDocument/2006/relationships" xmlns:p="http://schemas.openxmlformats.org/presentationml/2006/main">
   <p:cSld>
     <p:bg>
       <p:bgPr>
@@ -6539,7 +6738,14 @@
         <p:cNvGrpSpPr/>
         <p:nvPr/>
       </p:nvGrpSpPr>
-      <p:grpSpPr/>
+      <p:grpSpPr>
+        <a:xfrm>
+          <a:off x="0" y="0"/>
+          <a:ext cx="0" cy="0"/>
+          <a:chOff x="0" y="0"/>
+          <a:chExt cx="0" cy="0"/>
+        </a:xfrm>
+      </p:grpSpPr>
       <p:sp>
         <p:nvSpPr>
           <p:cNvPr id="2" name="Rectangle 1"/>
@@ -6580,6 +6786,7 @@
           <a:lstStyle/>
           <a:p>
             <a:pPr algn="ctr"/>
+            <a:endParaRPr/>
           </a:p>
         </p:txBody>
       </p:sp>
@@ -6623,6 +6830,7 @@
           <a:lstStyle/>
           <a:p>
             <a:pPr algn="ctr"/>
+            <a:endParaRPr/>
           </a:p>
         </p:txBody>
       </p:sp>
@@ -6647,7 +6855,9 @@
             <a:spAutoFit/>
           </a:bodyPr>
           <a:lstStyle/>
-          <a:p/>
+          <a:p>
+            <a:endParaRPr/>
+          </a:p>
           <a:p>
             <a:pPr algn="r">
               <a:spcBef>
@@ -6689,7 +6899,9 @@
             <a:spAutoFit/>
           </a:bodyPr>
           <a:lstStyle/>
-          <a:p/>
+          <a:p>
+            <a:endParaRPr/>
+          </a:p>
           <a:p>
             <a:pPr algn="l">
               <a:spcBef>
@@ -6744,7 +6956,7 @@
         </p:blipFill>
         <p:spPr>
           <a:xfrm>
-            <a:off x="548640" y="1143000"/>
+            <a:off x="450028" y="1051560"/>
             <a:ext cx="11064240" cy="2926080"/>
           </a:xfrm>
           <a:prstGeom prst="rect">
@@ -6794,6 +7006,7 @@
           <a:lstStyle/>
           <a:p>
             <a:pPr algn="ctr"/>
+            <a:endParaRPr/>
           </a:p>
         </p:txBody>
       </p:sp>
@@ -6818,7 +7031,9 @@
             <a:spAutoFit/>
           </a:bodyPr>
           <a:lstStyle/>
-          <a:p/>
+          <a:p>
+            <a:endParaRPr/>
+          </a:p>
           <a:p>
             <a:pPr algn="l">
               <a:spcBef>
@@ -6866,7 +7081,7 @@
 </file>
 
 <file path=ppt/slides/slide5.xml><?xml version="1.0" encoding="utf-8"?>
-<p:sld xmlns:a="http://schemas.openxmlformats.org/drawingml/2006/main" xmlns:p="http://schemas.openxmlformats.org/presentationml/2006/main" xmlns:r="http://schemas.openxmlformats.org/officeDocument/2006/relationships">
+<p:sld xmlns:a="http://schemas.openxmlformats.org/drawingml/2006/main" xmlns:r="http://schemas.openxmlformats.org/officeDocument/2006/relationships" xmlns:p="http://schemas.openxmlformats.org/presentationml/2006/main">
   <p:cSld>
     <p:bg>
       <p:bgPr>
@@ -6882,7 +7097,14 @@
         <p:cNvGrpSpPr/>
         <p:nvPr/>
       </p:nvGrpSpPr>
-      <p:grpSpPr/>
+      <p:grpSpPr>
+        <a:xfrm>
+          <a:off x="0" y="0"/>
+          <a:ext cx="0" cy="0"/>
+          <a:chOff x="0" y="0"/>
+          <a:chExt cx="0" cy="0"/>
+        </a:xfrm>
+      </p:grpSpPr>
       <p:sp>
         <p:nvSpPr>
           <p:cNvPr id="2" name="Rectangle 1"/>
@@ -6923,6 +7145,7 @@
           <a:lstStyle/>
           <a:p>
             <a:pPr algn="ctr"/>
+            <a:endParaRPr/>
           </a:p>
         </p:txBody>
       </p:sp>
@@ -6966,6 +7189,7 @@
           <a:lstStyle/>
           <a:p>
             <a:pPr algn="ctr"/>
+            <a:endParaRPr/>
           </a:p>
         </p:txBody>
       </p:sp>
@@ -6990,7 +7214,9 @@
             <a:spAutoFit/>
           </a:bodyPr>
           <a:lstStyle/>
-          <a:p/>
+          <a:p>
+            <a:endParaRPr/>
+          </a:p>
           <a:p>
             <a:pPr algn="r">
               <a:spcBef>
@@ -7032,7 +7258,9 @@
             <a:spAutoFit/>
           </a:bodyPr>
           <a:lstStyle/>
-          <a:p/>
+          <a:p>
+            <a:endParaRPr/>
+          </a:p>
           <a:p>
             <a:pPr algn="l">
               <a:spcBef>
@@ -7137,6 +7365,7 @@
           <a:lstStyle/>
           <a:p>
             <a:pPr algn="ctr"/>
+            <a:endParaRPr/>
           </a:p>
         </p:txBody>
       </p:sp>
@@ -7161,7 +7390,9 @@
             <a:spAutoFit/>
           </a:bodyPr>
           <a:lstStyle/>
-          <a:p/>
+          <a:p>
+            <a:endParaRPr/>
+          </a:p>
           <a:p>
             <a:pPr algn="l">
               <a:spcBef>
@@ -7332,6 +7563,7 @@
           <a:lstStyle/>
           <a:p>
             <a:pPr algn="ctr"/>
+            <a:endParaRPr/>
           </a:p>
         </p:txBody>
       </p:sp>
@@ -7356,7 +7588,9 @@
             <a:spAutoFit/>
           </a:bodyPr>
           <a:lstStyle/>
-          <a:p/>
+          <a:p>
+            <a:endParaRPr/>
+          </a:p>
           <a:p>
             <a:pPr algn="l">
               <a:spcBef>
@@ -7404,7 +7638,7 @@
 </file>
 
 <file path=ppt/slides/slide6.xml><?xml version="1.0" encoding="utf-8"?>
-<p:sld xmlns:a="http://schemas.openxmlformats.org/drawingml/2006/main" xmlns:p="http://schemas.openxmlformats.org/presentationml/2006/main" xmlns:r="http://schemas.openxmlformats.org/officeDocument/2006/relationships">
+<p:sld xmlns:a="http://schemas.openxmlformats.org/drawingml/2006/main" xmlns:r="http://schemas.openxmlformats.org/officeDocument/2006/relationships" xmlns:p="http://schemas.openxmlformats.org/presentationml/2006/main">
   <p:cSld>
     <p:bg>
       <p:bgPr>
@@ -7420,7 +7654,14 @@
         <p:cNvGrpSpPr/>
         <p:nvPr/>
       </p:nvGrpSpPr>
-      <p:grpSpPr/>
+      <p:grpSpPr>
+        <a:xfrm>
+          <a:off x="0" y="0"/>
+          <a:ext cx="0" cy="0"/>
+          <a:chOff x="0" y="0"/>
+          <a:chExt cx="0" cy="0"/>
+        </a:xfrm>
+      </p:grpSpPr>
       <p:sp>
         <p:nvSpPr>
           <p:cNvPr id="2" name="Rectangle 1"/>
@@ -7461,6 +7702,7 @@
           <a:lstStyle/>
           <a:p>
             <a:pPr algn="ctr"/>
+            <a:endParaRPr/>
           </a:p>
         </p:txBody>
       </p:sp>
@@ -7504,6 +7746,7 @@
           <a:lstStyle/>
           <a:p>
             <a:pPr algn="ctr"/>
+            <a:endParaRPr/>
           </a:p>
         </p:txBody>
       </p:sp>
@@ -7528,7 +7771,9 @@
             <a:spAutoFit/>
           </a:bodyPr>
           <a:lstStyle/>
-          <a:p/>
+          <a:p>
+            <a:endParaRPr/>
+          </a:p>
           <a:p>
             <a:pPr algn="r">
               <a:spcBef>
@@ -7570,7 +7815,9 @@
             <a:spAutoFit/>
           </a:bodyPr>
           <a:lstStyle/>
-          <a:p/>
+          <a:p>
+            <a:endParaRPr/>
+          </a:p>
           <a:p>
             <a:pPr algn="l">
               <a:spcBef>
@@ -7675,6 +7922,7 @@
           <a:lstStyle/>
           <a:p>
             <a:pPr algn="ctr"/>
+            <a:endParaRPr/>
           </a:p>
         </p:txBody>
       </p:sp>
@@ -7699,7 +7947,9 @@
             <a:spAutoFit/>
           </a:bodyPr>
           <a:lstStyle/>
-          <a:p/>
+          <a:p>
+            <a:endParaRPr/>
+          </a:p>
           <a:p>
             <a:pPr algn="l">
               <a:spcBef>
@@ -7819,7 +8069,7 @@
 </file>
 
 <file path=ppt/slides/slide7.xml><?xml version="1.0" encoding="utf-8"?>
-<p:sld xmlns:a="http://schemas.openxmlformats.org/drawingml/2006/main" xmlns:p="http://schemas.openxmlformats.org/presentationml/2006/main" xmlns:r="http://schemas.openxmlformats.org/officeDocument/2006/relationships">
+<p:sld xmlns:a="http://schemas.openxmlformats.org/drawingml/2006/main" xmlns:r="http://schemas.openxmlformats.org/officeDocument/2006/relationships" xmlns:p="http://schemas.openxmlformats.org/presentationml/2006/main">
   <p:cSld>
     <p:bg>
       <p:bgPr>
@@ -7835,7 +8085,14 @@
         <p:cNvGrpSpPr/>
         <p:nvPr/>
       </p:nvGrpSpPr>
-      <p:grpSpPr/>
+      <p:grpSpPr>
+        <a:xfrm>
+          <a:off x="0" y="0"/>
+          <a:ext cx="0" cy="0"/>
+          <a:chOff x="0" y="0"/>
+          <a:chExt cx="0" cy="0"/>
+        </a:xfrm>
+      </p:grpSpPr>
       <p:sp>
         <p:nvSpPr>
           <p:cNvPr id="2" name="Rectangle 1"/>
@@ -7876,6 +8133,7 @@
           <a:lstStyle/>
           <a:p>
             <a:pPr algn="ctr"/>
+            <a:endParaRPr/>
           </a:p>
         </p:txBody>
       </p:sp>
@@ -7919,6 +8177,7 @@
           <a:lstStyle/>
           <a:p>
             <a:pPr algn="ctr"/>
+            <a:endParaRPr/>
           </a:p>
         </p:txBody>
       </p:sp>
@@ -7943,7 +8202,9 @@
             <a:spAutoFit/>
           </a:bodyPr>
           <a:lstStyle/>
-          <a:p/>
+          <a:p>
+            <a:endParaRPr/>
+          </a:p>
           <a:p>
             <a:pPr algn="r">
               <a:spcBef>
@@ -7985,7 +8246,9 @@
             <a:spAutoFit/>
           </a:bodyPr>
           <a:lstStyle/>
-          <a:p/>
+          <a:p>
+            <a:endParaRPr/>
+          </a:p>
           <a:p>
             <a:pPr algn="l">
               <a:spcBef>
@@ -8066,6 +8329,7 @@
           <a:lstStyle/>
           <a:p>
             <a:pPr algn="ctr"/>
+            <a:endParaRPr/>
           </a:p>
         </p:txBody>
       </p:sp>
@@ -8090,7 +8354,9 @@
             <a:spAutoFit/>
           </a:bodyPr>
           <a:lstStyle/>
-          <a:p/>
+          <a:p>
+            <a:endParaRPr/>
+          </a:p>
           <a:p>
             <a:pPr algn="l">
               <a:spcBef>
@@ -8351,6 +8617,7 @@
           <a:lstStyle/>
           <a:p>
             <a:pPr algn="ctr"/>
+            <a:endParaRPr/>
           </a:p>
         </p:txBody>
       </p:sp>
@@ -8375,7 +8642,9 @@
             <a:spAutoFit/>
           </a:bodyPr>
           <a:lstStyle/>
-          <a:p/>
+          <a:p>
+            <a:endParaRPr/>
+          </a:p>
           <a:p>
             <a:pPr algn="l">
               <a:spcBef>
@@ -8549,7 +8818,7 @@
 </file>
 
 <file path=ppt/slides/slide8.xml><?xml version="1.0" encoding="utf-8"?>
-<p:sld xmlns:a="http://schemas.openxmlformats.org/drawingml/2006/main" xmlns:p="http://schemas.openxmlformats.org/presentationml/2006/main" xmlns:r="http://schemas.openxmlformats.org/officeDocument/2006/relationships">
+<p:sld xmlns:a="http://schemas.openxmlformats.org/drawingml/2006/main" xmlns:r="http://schemas.openxmlformats.org/officeDocument/2006/relationships" xmlns:p="http://schemas.openxmlformats.org/presentationml/2006/main">
   <p:cSld>
     <p:bg>
       <p:bgPr>
@@ -8565,7 +8834,14 @@
         <p:cNvGrpSpPr/>
         <p:nvPr/>
       </p:nvGrpSpPr>
-      <p:grpSpPr/>
+      <p:grpSpPr>
+        <a:xfrm>
+          <a:off x="0" y="0"/>
+          <a:ext cx="0" cy="0"/>
+          <a:chOff x="0" y="0"/>
+          <a:chExt cx="0" cy="0"/>
+        </a:xfrm>
+      </p:grpSpPr>
       <p:sp>
         <p:nvSpPr>
           <p:cNvPr id="2" name="Rectangle 1"/>
@@ -8606,6 +8882,7 @@
           <a:lstStyle/>
           <a:p>
             <a:pPr algn="ctr"/>
+            <a:endParaRPr/>
           </a:p>
         </p:txBody>
       </p:sp>
@@ -8649,6 +8926,7 @@
           <a:lstStyle/>
           <a:p>
             <a:pPr algn="ctr"/>
+            <a:endParaRPr/>
           </a:p>
         </p:txBody>
       </p:sp>
@@ -8673,7 +8951,9 @@
             <a:spAutoFit/>
           </a:bodyPr>
           <a:lstStyle/>
-          <a:p/>
+          <a:p>
+            <a:endParaRPr/>
+          </a:p>
           <a:p>
             <a:pPr algn="r">
               <a:spcBef>
@@ -8715,7 +8995,9 @@
             <a:spAutoFit/>
           </a:bodyPr>
           <a:lstStyle/>
-          <a:p/>
+          <a:p>
+            <a:endParaRPr/>
+          </a:p>
           <a:p>
             <a:pPr algn="l">
               <a:spcBef>
@@ -8820,6 +9102,7 @@
           <a:lstStyle/>
           <a:p>
             <a:pPr algn="ctr"/>
+            <a:endParaRPr/>
           </a:p>
         </p:txBody>
       </p:sp>
@@ -8844,7 +9127,9 @@
             <a:spAutoFit/>
           </a:bodyPr>
           <a:lstStyle/>
-          <a:p/>
+          <a:p>
+            <a:endParaRPr/>
+          </a:p>
           <a:p>
             <a:pPr algn="l">
               <a:spcBef>
@@ -9033,6 +9318,7 @@
           <a:lstStyle/>
           <a:p>
             <a:pPr algn="ctr"/>
+            <a:endParaRPr/>
           </a:p>
         </p:txBody>
       </p:sp>
@@ -9057,7 +9343,9 @@
             <a:spAutoFit/>
           </a:bodyPr>
           <a:lstStyle/>
-          <a:p/>
+          <a:p>
+            <a:endParaRPr/>
+          </a:p>
           <a:p>
             <a:pPr algn="l">
               <a:spcBef>
@@ -9087,7 +9375,7 @@
 </file>
 
 <file path=ppt/slides/slide9.xml><?xml version="1.0" encoding="utf-8"?>
-<p:sld xmlns:a="http://schemas.openxmlformats.org/drawingml/2006/main" xmlns:p="http://schemas.openxmlformats.org/presentationml/2006/main" xmlns:r="http://schemas.openxmlformats.org/officeDocument/2006/relationships">
+<p:sld xmlns:a="http://schemas.openxmlformats.org/drawingml/2006/main" xmlns:r="http://schemas.openxmlformats.org/officeDocument/2006/relationships" xmlns:p="http://schemas.openxmlformats.org/presentationml/2006/main">
   <p:cSld>
     <p:bg>
       <p:bgPr>
@@ -9103,7 +9391,14 @@
         <p:cNvGrpSpPr/>
         <p:nvPr/>
       </p:nvGrpSpPr>
-      <p:grpSpPr/>
+      <p:grpSpPr>
+        <a:xfrm>
+          <a:off x="0" y="0"/>
+          <a:ext cx="0" cy="0"/>
+          <a:chOff x="0" y="0"/>
+          <a:chExt cx="0" cy="0"/>
+        </a:xfrm>
+      </p:grpSpPr>
       <p:sp>
         <p:nvSpPr>
           <p:cNvPr id="2" name="Rectangle 1"/>
@@ -9144,6 +9439,7 @@
           <a:lstStyle/>
           <a:p>
             <a:pPr algn="ctr"/>
+            <a:endParaRPr/>
           </a:p>
         </p:txBody>
       </p:sp>
@@ -9187,6 +9483,7 @@
           <a:lstStyle/>
           <a:p>
             <a:pPr algn="ctr"/>
+            <a:endParaRPr/>
           </a:p>
         </p:txBody>
       </p:sp>
@@ -9211,7 +9508,9 @@
             <a:spAutoFit/>
           </a:bodyPr>
           <a:lstStyle/>
-          <a:p/>
+          <a:p>
+            <a:endParaRPr/>
+          </a:p>
           <a:p>
             <a:pPr algn="r">
               <a:spcBef>
@@ -9253,7 +9552,9 @@
             <a:spAutoFit/>
           </a:bodyPr>
           <a:lstStyle/>
-          <a:p/>
+          <a:p>
+            <a:endParaRPr/>
+          </a:p>
           <a:p>
             <a:pPr algn="l">
               <a:spcBef>
@@ -9358,6 +9659,7 @@
           <a:lstStyle/>
           <a:p>
             <a:pPr algn="ctr"/>
+            <a:endParaRPr/>
           </a:p>
         </p:txBody>
       </p:sp>
@@ -9382,7 +9684,9 @@
             <a:spAutoFit/>
           </a:bodyPr>
           <a:lstStyle/>
-          <a:p/>
+          <a:p>
+            <a:endParaRPr/>
+          </a:p>
           <a:p>
             <a:pPr algn="l">
               <a:spcBef>
@@ -9589,6 +9893,7 @@
           <a:lstStyle/>
           <a:p>
             <a:pPr algn="ctr"/>
+            <a:endParaRPr/>
           </a:p>
         </p:txBody>
       </p:sp>
@@ -9613,7 +9918,9 @@
             <a:spAutoFit/>
           </a:bodyPr>
           <a:lstStyle/>
-          <a:p/>
+          <a:p>
+            <a:endParaRPr/>
+          </a:p>
           <a:p>
             <a:pPr algn="l">
               <a:spcBef>

</xml_diff>